<commit_message>
Refine handoff doc + remove make_dummy_data.R + update pptx
- Docs/RFind-G_handoff.md/html:
  - 「解釈サマリ」→ 「解釈」
  - Fold 再現性段落を簡潔化 (ROSMAP 特異的、別 cohort では適宜書き換え)
- Docs/260428_RFindG.pptx: 内容更新
- Code/make_dummy_data.R: 削除 (dummy データは既に生成済 + repo に commit 済のため不要)
</commit_message>
<xml_diff>
--- a/Docs/260428_RFindG.pptx
+++ b/Docs/260428_RFindG.pptx
@@ -205,7 +205,7 @@
           <a:p>
             <a:fld id="{187D68F0-4DB2-164D-8B00-B7B403E117A1}" type="datetimeFigureOut">
               <a:rPr kumimoji="1" lang="ja-JP" altLang="en-US" smtClean="0"/>
-              <a:t>2025/6/25</a:t>
+              <a:t>2026/4/28</a:t>
             </a:fld>
             <a:endParaRPr kumimoji="1" lang="ja-JP" altLang="en-US"/>
           </a:p>
@@ -651,7 +651,7 @@
           <a:p>
             <a:fld id="{905090EB-9577-B448-83AE-3F83FF61B364}" type="datetimeFigureOut">
               <a:rPr kumimoji="1" lang="ja-JP" altLang="en-US" smtClean="0"/>
-              <a:t>2025/6/25</a:t>
+              <a:t>2026/4/28</a:t>
             </a:fld>
             <a:endParaRPr kumimoji="1" lang="ja-JP" altLang="en-US"/>
           </a:p>
@@ -881,7 +881,7 @@
           <a:p>
             <a:fld id="{905090EB-9577-B448-83AE-3F83FF61B364}" type="datetimeFigureOut">
               <a:rPr kumimoji="1" lang="ja-JP" altLang="en-US" smtClean="0"/>
-              <a:t>2025/6/25</a:t>
+              <a:t>2026/4/28</a:t>
             </a:fld>
             <a:endParaRPr kumimoji="1" lang="ja-JP" altLang="en-US"/>
           </a:p>
@@ -1121,7 +1121,7 @@
           <a:p>
             <a:fld id="{905090EB-9577-B448-83AE-3F83FF61B364}" type="datetimeFigureOut">
               <a:rPr kumimoji="1" lang="ja-JP" altLang="en-US" smtClean="0"/>
-              <a:t>2025/6/25</a:t>
+              <a:t>2026/4/28</a:t>
             </a:fld>
             <a:endParaRPr kumimoji="1" lang="ja-JP" altLang="en-US"/>
           </a:p>
@@ -1351,7 +1351,7 @@
           <a:p>
             <a:fld id="{905090EB-9577-B448-83AE-3F83FF61B364}" type="datetimeFigureOut">
               <a:rPr kumimoji="1" lang="ja-JP" altLang="en-US" smtClean="0"/>
-              <a:t>2025/6/25</a:t>
+              <a:t>2026/4/28</a:t>
             </a:fld>
             <a:endParaRPr kumimoji="1" lang="ja-JP" altLang="en-US"/>
           </a:p>
@@ -1626,7 +1626,7 @@
           <a:p>
             <a:fld id="{905090EB-9577-B448-83AE-3F83FF61B364}" type="datetimeFigureOut">
               <a:rPr kumimoji="1" lang="ja-JP" altLang="en-US" smtClean="0"/>
-              <a:t>2025/6/25</a:t>
+              <a:t>2026/4/28</a:t>
             </a:fld>
             <a:endParaRPr kumimoji="1" lang="ja-JP" altLang="en-US"/>
           </a:p>
@@ -1955,7 +1955,7 @@
           <a:p>
             <a:fld id="{905090EB-9577-B448-83AE-3F83FF61B364}" type="datetimeFigureOut">
               <a:rPr kumimoji="1" lang="ja-JP" altLang="en-US" smtClean="0"/>
-              <a:t>2025/6/25</a:t>
+              <a:t>2026/4/28</a:t>
             </a:fld>
             <a:endParaRPr kumimoji="1" lang="ja-JP" altLang="en-US"/>
           </a:p>
@@ -2431,7 +2431,7 @@
           <a:p>
             <a:fld id="{905090EB-9577-B448-83AE-3F83FF61B364}" type="datetimeFigureOut">
               <a:rPr kumimoji="1" lang="ja-JP" altLang="en-US" smtClean="0"/>
-              <a:t>2025/6/25</a:t>
+              <a:t>2026/4/28</a:t>
             </a:fld>
             <a:endParaRPr kumimoji="1" lang="ja-JP" altLang="en-US"/>
           </a:p>
@@ -2572,7 +2572,7 @@
           <a:p>
             <a:fld id="{905090EB-9577-B448-83AE-3F83FF61B364}" type="datetimeFigureOut">
               <a:rPr kumimoji="1" lang="ja-JP" altLang="en-US" smtClean="0"/>
-              <a:t>2025/6/25</a:t>
+              <a:t>2026/4/28</a:t>
             </a:fld>
             <a:endParaRPr kumimoji="1" lang="ja-JP" altLang="en-US"/>
           </a:p>
@@ -2685,7 +2685,7 @@
           <a:p>
             <a:fld id="{905090EB-9577-B448-83AE-3F83FF61B364}" type="datetimeFigureOut">
               <a:rPr kumimoji="1" lang="ja-JP" altLang="en-US" smtClean="0"/>
-              <a:t>2025/6/25</a:t>
+              <a:t>2026/4/28</a:t>
             </a:fld>
             <a:endParaRPr kumimoji="1" lang="ja-JP" altLang="en-US"/>
           </a:p>
@@ -3028,7 +3028,7 @@
           <a:p>
             <a:fld id="{905090EB-9577-B448-83AE-3F83FF61B364}" type="datetimeFigureOut">
               <a:rPr kumimoji="1" lang="ja-JP" altLang="en-US" smtClean="0"/>
-              <a:t>2025/6/25</a:t>
+              <a:t>2026/4/28</a:t>
             </a:fld>
             <a:endParaRPr kumimoji="1" lang="ja-JP" altLang="en-US"/>
           </a:p>
@@ -3316,7 +3316,7 @@
           <a:p>
             <a:fld id="{905090EB-9577-B448-83AE-3F83FF61B364}" type="datetimeFigureOut">
               <a:rPr kumimoji="1" lang="ja-JP" altLang="en-US" smtClean="0"/>
-              <a:t>2025/6/25</a:t>
+              <a:t>2026/4/28</a:t>
             </a:fld>
             <a:endParaRPr kumimoji="1" lang="ja-JP" altLang="en-US"/>
           </a:p>
@@ -3589,7 +3589,7 @@
           <a:p>
             <a:fld id="{905090EB-9577-B448-83AE-3F83FF61B364}" type="datetimeFigureOut">
               <a:rPr kumimoji="1" lang="ja-JP" altLang="en-US" smtClean="0"/>
-              <a:t>2025/6/25</a:t>
+              <a:t>2026/4/28</a:t>
             </a:fld>
             <a:endParaRPr kumimoji="1" lang="ja-JP" altLang="en-US"/>
           </a:p>
@@ -33927,13 +33927,13 @@
           <p:nvPr>
             <p:extLst>
               <p:ext uri="{D42A27DB-BD31-4B8C-83A1-F6EECF244321}">
-                <p14:modId xmlns:p14="http://schemas.microsoft.com/office/powerpoint/2010/main" val="1347464768"/>
+                <p14:modId xmlns:p14="http://schemas.microsoft.com/office/powerpoint/2010/main" val="4195381500"/>
               </p:ext>
             </p:extLst>
           </p:nvPr>
         </p:nvGraphicFramePr>
         <p:xfrm>
-          <a:off x="1311119" y="1097921"/>
+          <a:off x="1228828" y="1097920"/>
           <a:ext cx="2625958" cy="1192517"/>
         </p:xfrm>
         <a:graphic>
@@ -34020,7 +34020,7 @@
                           <a:latin typeface="Helvetica" pitchFamily="2" charset="0"/>
                           <a:ea typeface="游ゴシック" panose="020B0400000000000000" pitchFamily="34" charset="-128"/>
                         </a:rPr>
-                        <a:t>Cntl_01</a:t>
+                        <a:t>健常01</a:t>
                       </a:r>
                     </a:p>
                   </a:txBody>
@@ -34041,7 +34041,7 @@
                           <a:latin typeface="Helvetica" pitchFamily="2" charset="0"/>
                           <a:ea typeface="+mn-ea"/>
                         </a:rPr>
-                        <a:t>Cntl</a:t>
+                        <a:t>健常</a:t>
                       </a:r>
                       <a:r>
                         <a:rPr lang="en-US" sz="1000" b="0" i="0" u="none" strike="noStrike" dirty="0">
@@ -34052,7 +34052,7 @@
                           <a:latin typeface="Helvetica" pitchFamily="2" charset="0"/>
                           <a:ea typeface="游ゴシック" panose="020B0400000000000000" pitchFamily="34" charset="-128"/>
                         </a:rPr>
-                        <a:t>_02</a:t>
+                        <a:t>02</a:t>
                       </a:r>
                     </a:p>
                   </a:txBody>
@@ -34073,7 +34073,7 @@
                           <a:latin typeface="Helvetica" pitchFamily="2" charset="0"/>
                           <a:ea typeface="+mn-ea"/>
                         </a:rPr>
-                        <a:t>Cntl</a:t>
+                        <a:t>健常</a:t>
                       </a:r>
                       <a:r>
                         <a:rPr lang="en-US" sz="1000" b="0" i="0" u="none" strike="noStrike" dirty="0">
@@ -34084,7 +34084,7 @@
                           <a:latin typeface="Helvetica" pitchFamily="2" charset="0"/>
                           <a:ea typeface="游ゴシック" panose="020B0400000000000000" pitchFamily="34" charset="-128"/>
                         </a:rPr>
-                        <a:t>_03</a:t>
+                        <a:t>03</a:t>
                       </a:r>
                     </a:p>
                   </a:txBody>
@@ -34105,7 +34105,7 @@
                           <a:latin typeface="Helvetica" pitchFamily="2" charset="0"/>
                           <a:ea typeface="+mn-ea"/>
                         </a:rPr>
-                        <a:t>Cntl</a:t>
+                        <a:t>健常</a:t>
                       </a:r>
                       <a:r>
                         <a:rPr lang="en-US" sz="1000" b="0" i="0" u="none" strike="noStrike" dirty="0">
@@ -34116,7 +34116,7 @@
                           <a:latin typeface="Helvetica" pitchFamily="2" charset="0"/>
                           <a:ea typeface="游ゴシック" panose="020B0400000000000000" pitchFamily="34" charset="-128"/>
                         </a:rPr>
-                        <a:t>_04</a:t>
+                        <a:t>04</a:t>
                       </a:r>
                     </a:p>
                   </a:txBody>
@@ -34137,7 +34137,7 @@
                           <a:latin typeface="Helvetica" pitchFamily="2" charset="0"/>
                           <a:ea typeface="+mn-ea"/>
                         </a:rPr>
-                        <a:t>Cntl</a:t>
+                        <a:t>健常</a:t>
                       </a:r>
                       <a:r>
                         <a:rPr lang="en-US" sz="1000" b="0" i="0" u="none" strike="noStrike" dirty="0">
@@ -34148,7 +34148,7 @@
                           <a:latin typeface="Helvetica" pitchFamily="2" charset="0"/>
                           <a:ea typeface="游ゴシック" panose="020B0400000000000000" pitchFamily="34" charset="-128"/>
                         </a:rPr>
-                        <a:t>_05</a:t>
+                        <a:t>05</a:t>
                       </a:r>
                     </a:p>
                   </a:txBody>
@@ -34727,7 +34727,7 @@
           <p:nvPr>
             <p:extLst>
               <p:ext uri="{D42A27DB-BD31-4B8C-83A1-F6EECF244321}">
-                <p14:modId xmlns:p14="http://schemas.microsoft.com/office/powerpoint/2010/main" val="4241420243"/>
+                <p14:modId xmlns:p14="http://schemas.microsoft.com/office/powerpoint/2010/main" val="1905242968"/>
               </p:ext>
             </p:extLst>
           </p:nvPr>
@@ -34820,7 +34820,7 @@
                           <a:latin typeface="Helvetica" pitchFamily="2" charset="0"/>
                           <a:ea typeface="游ゴシック" panose="020B0400000000000000" pitchFamily="34" charset="-128"/>
                         </a:rPr>
-                        <a:t>ASD_01</a:t>
+                        <a:t>患者01</a:t>
                       </a:r>
                     </a:p>
                   </a:txBody>
@@ -34833,6 +34833,17 @@
                     <a:p>
                       <a:pPr algn="l" fontAlgn="ctr"/>
                       <a:r>
+                        <a:rPr lang="en-US" altLang="ja-JP" sz="1000" b="0" i="0" u="none" strike="noStrike" dirty="0">
+                          <a:solidFill>
+                            <a:schemeClr val="bg1"/>
+                          </a:solidFill>
+                          <a:effectLst/>
+                          <a:latin typeface="Helvetica" pitchFamily="2" charset="0"/>
+                          <a:ea typeface="+mn-ea"/>
+                        </a:rPr>
+                        <a:t>患者</a:t>
+                      </a:r>
+                      <a:r>
                         <a:rPr lang="en-US" sz="1000" b="0" i="0" u="none" strike="noStrike" dirty="0">
                           <a:solidFill>
                             <a:schemeClr val="bg1"/>
@@ -34841,7 +34852,7 @@
                           <a:latin typeface="Helvetica" pitchFamily="2" charset="0"/>
                           <a:ea typeface="游ゴシック" panose="020B0400000000000000" pitchFamily="34" charset="-128"/>
                         </a:rPr>
-                        <a:t>ASD_02</a:t>
+                        <a:t>02</a:t>
                       </a:r>
                     </a:p>
                   </a:txBody>
@@ -34854,6 +34865,17 @@
                     <a:p>
                       <a:pPr algn="l" fontAlgn="ctr"/>
                       <a:r>
+                        <a:rPr lang="en-US" altLang="ja-JP" sz="1000" b="0" i="0" u="none" strike="noStrike" dirty="0">
+                          <a:solidFill>
+                            <a:schemeClr val="bg1"/>
+                          </a:solidFill>
+                          <a:effectLst/>
+                          <a:latin typeface="Helvetica" pitchFamily="2" charset="0"/>
+                          <a:ea typeface="+mn-ea"/>
+                        </a:rPr>
+                        <a:t>患者</a:t>
+                      </a:r>
+                      <a:r>
                         <a:rPr lang="en-US" sz="1000" b="0" i="0" u="none" strike="noStrike" dirty="0">
                           <a:solidFill>
                             <a:schemeClr val="bg1"/>
@@ -34862,7 +34884,7 @@
                           <a:latin typeface="Helvetica" pitchFamily="2" charset="0"/>
                           <a:ea typeface="游ゴシック" panose="020B0400000000000000" pitchFamily="34" charset="-128"/>
                         </a:rPr>
-                        <a:t>ASD_03</a:t>
+                        <a:t>03</a:t>
                       </a:r>
                     </a:p>
                   </a:txBody>
@@ -34875,6 +34897,17 @@
                     <a:p>
                       <a:pPr algn="l" fontAlgn="ctr"/>
                       <a:r>
+                        <a:rPr lang="en-US" altLang="ja-JP" sz="1000" b="0" i="0" u="none" strike="noStrike" dirty="0">
+                          <a:solidFill>
+                            <a:schemeClr val="bg1"/>
+                          </a:solidFill>
+                          <a:effectLst/>
+                          <a:latin typeface="Helvetica" pitchFamily="2" charset="0"/>
+                          <a:ea typeface="+mn-ea"/>
+                        </a:rPr>
+                        <a:t>患者</a:t>
+                      </a:r>
+                      <a:r>
                         <a:rPr lang="en-US" sz="1000" b="0" i="0" u="none" strike="noStrike" dirty="0">
                           <a:solidFill>
                             <a:schemeClr val="bg1"/>
@@ -34883,7 +34916,7 @@
                           <a:latin typeface="Helvetica" pitchFamily="2" charset="0"/>
                           <a:ea typeface="游ゴシック" panose="020B0400000000000000" pitchFamily="34" charset="-128"/>
                         </a:rPr>
-                        <a:t>ASD_04</a:t>
+                        <a:t>04</a:t>
                       </a:r>
                     </a:p>
                   </a:txBody>
@@ -34896,6 +34929,17 @@
                     <a:p>
                       <a:pPr algn="l" fontAlgn="ctr"/>
                       <a:r>
+                        <a:rPr lang="en-US" altLang="ja-JP" sz="1000" b="0" i="0" u="none" strike="noStrike" dirty="0">
+                          <a:solidFill>
+                            <a:schemeClr val="bg1"/>
+                          </a:solidFill>
+                          <a:effectLst/>
+                          <a:latin typeface="Helvetica" pitchFamily="2" charset="0"/>
+                          <a:ea typeface="+mn-ea"/>
+                        </a:rPr>
+                        <a:t>患者</a:t>
+                      </a:r>
+                      <a:r>
                         <a:rPr lang="en-US" sz="1000" b="0" i="0" u="none" strike="noStrike" dirty="0">
                           <a:solidFill>
                             <a:schemeClr val="bg1"/>
@@ -34904,7 +34948,7 @@
                           <a:latin typeface="Helvetica" pitchFamily="2" charset="0"/>
                           <a:ea typeface="游ゴシック" panose="020B0400000000000000" pitchFamily="34" charset="-128"/>
                         </a:rPr>
-                        <a:t>ASD_05</a:t>
+                        <a:t>05</a:t>
                       </a:r>
                     </a:p>
                   </a:txBody>
@@ -35483,7 +35527,7 @@
         <p:spPr>
           <a:xfrm>
             <a:off x="0" y="23969"/>
-            <a:ext cx="3839513" cy="369332"/>
+            <a:ext cx="2903359" cy="369332"/>
           </a:xfrm>
           <a:prstGeom prst="rect">
             <a:avLst/>
@@ -35496,34 +35540,6 @@
           </a:bodyPr>
           <a:lstStyle/>
           <a:p>
-            <a:r>
-              <a:rPr lang="en-US" altLang="ja-JP" u="sng" dirty="0">
-                <a:latin typeface="Helvetica" pitchFamily="2" charset="0"/>
-                <a:ea typeface="BIZ UDGothic" panose="020B0400000000000000" pitchFamily="49" charset="-128"/>
-              </a:rPr>
-              <a:t>(4. </a:t>
-            </a:r>
-            <a:r>
-              <a:rPr kumimoji="1" lang="ja-JP" altLang="en-US" u="sng">
-                <a:latin typeface="Helvetica" pitchFamily="2" charset="0"/>
-                <a:ea typeface="BIZ UDGothic" panose="020B0400000000000000" pitchFamily="49" charset="-128"/>
-              </a:rPr>
-              <a:t>補足</a:t>
-            </a:r>
-            <a:r>
-              <a:rPr kumimoji="1" lang="en-US" altLang="ja-JP" u="sng" dirty="0">
-                <a:latin typeface="Helvetica" pitchFamily="2" charset="0"/>
-                <a:ea typeface="BIZ UDGothic" panose="020B0400000000000000" pitchFamily="49" charset="-128"/>
-              </a:rPr>
-              <a:t>)</a:t>
-            </a:r>
-            <a:r>
-              <a:rPr lang="en-US" altLang="ja-JP" u="sng" dirty="0">
-                <a:latin typeface="Helvetica" pitchFamily="2" charset="0"/>
-                <a:ea typeface="BIZ UDGothic" panose="020B0400000000000000" pitchFamily="49" charset="-128"/>
-              </a:rPr>
-              <a:t> </a:t>
-            </a:r>
             <a:r>
               <a:rPr lang="en-US" altLang="ja-JP" u="sng" dirty="0" err="1">
                 <a:latin typeface="Helvetica" pitchFamily="2" charset="0"/>
@@ -35566,8 +35582,8 @@
         </p:nvSpPr>
         <p:spPr>
           <a:xfrm>
-            <a:off x="2593811" y="2270872"/>
-            <a:ext cx="1380506" cy="230832"/>
+            <a:off x="3456802" y="189273"/>
+            <a:ext cx="883575" cy="784830"/>
           </a:xfrm>
           <a:prstGeom prst="rect">
             <a:avLst/>
@@ -35581,92 +35597,46 @@
           <a:lstStyle/>
           <a:p>
             <a:r>
+              <a:rPr lang="ja-JP" altLang="en-US" sz="900">
+                <a:latin typeface="Helvetica" pitchFamily="2" charset="0"/>
+              </a:rPr>
+              <a:t>健常者平均</a:t>
+            </a:r>
+            <a:endParaRPr lang="en-US" altLang="ja-JP" sz="900" dirty="0">
+              <a:latin typeface="Helvetica" pitchFamily="2" charset="0"/>
+            </a:endParaRPr>
+          </a:p>
+          <a:p>
+            <a:r>
               <a:rPr lang="en-US" altLang="ja-JP" sz="900" dirty="0">
                 <a:latin typeface="Helvetica" pitchFamily="2" charset="0"/>
               </a:rPr>
-              <a:t>SNP_D: </a:t>
-            </a:r>
-            <a:r>
-              <a:rPr lang="en-US" altLang="ja-JP" sz="900" dirty="0" err="1">
-                <a:latin typeface="Helvetica" pitchFamily="2" charset="0"/>
-              </a:rPr>
-              <a:t>Cntl_ave</a:t>
-            </a:r>
+              <a:t>SNP_A = 0.2</a:t>
+            </a:r>
+          </a:p>
+          <a:p>
             <a:r>
               <a:rPr lang="en-US" altLang="ja-JP" sz="900" dirty="0">
                 <a:latin typeface="Helvetica" pitchFamily="2" charset="0"/>
               </a:rPr>
-              <a:t> = 0.2</a:t>
-            </a:r>
-          </a:p>
-        </p:txBody>
-      </p:sp>
-      <p:sp>
-        <p:nvSpPr>
-          <p:cNvPr id="9" name="テキスト ボックス 8">
-            <a:extLst>
-              <a:ext uri="{FF2B5EF4-FFF2-40B4-BE49-F238E27FC236}">
-                <a16:creationId xmlns:a16="http://schemas.microsoft.com/office/drawing/2014/main" id="{1960F6F7-0D5B-30D7-0200-54E6423CA7D4}"/>
-              </a:ext>
-            </a:extLst>
-          </p:cNvPr>
-          <p:cNvSpPr txBox="1"/>
-          <p:nvPr/>
-        </p:nvSpPr>
-        <p:spPr>
-          <a:xfrm>
-            <a:off x="9097729" y="1865591"/>
-            <a:ext cx="1452642" cy="523220"/>
-          </a:xfrm>
-          <a:prstGeom prst="rect">
-            <a:avLst/>
-          </a:prstGeom>
-          <a:noFill/>
-        </p:spPr>
-        <p:txBody>
-          <a:bodyPr wrap="none" rtlCol="0">
-            <a:spAutoFit/>
-          </a:bodyPr>
-          <a:lstStyle/>
-          <a:p>
-            <a:r>
-              <a:rPr lang="en-US" altLang="ja-JP" sz="1400" dirty="0">
-                <a:latin typeface="Helvetica" pitchFamily="2" charset="0"/>
-                <a:ea typeface="BIZ UDGothic" panose="020B0400000000000000" pitchFamily="49" charset="-128"/>
-              </a:rPr>
-              <a:t>β=0</a:t>
-            </a:r>
-            <a:r>
-              <a:rPr lang="ja-JP" altLang="en-US" sz="1400">
-                <a:latin typeface="Helvetica" pitchFamily="2" charset="0"/>
-                <a:ea typeface="BIZ UDGothic" panose="020B0400000000000000" pitchFamily="49" charset="-128"/>
-              </a:rPr>
-              <a:t>なので</a:t>
-            </a:r>
-            <a:endParaRPr lang="en-US" altLang="ja-JP" sz="1400" dirty="0">
-              <a:latin typeface="Helvetica" pitchFamily="2" charset="0"/>
-              <a:ea typeface="BIZ UDGothic" panose="020B0400000000000000" pitchFamily="49" charset="-128"/>
-            </a:endParaRPr>
+              <a:t>SNP_B = 0.4</a:t>
+            </a:r>
           </a:p>
           <a:p>
             <a:r>
-              <a:rPr lang="en-US" altLang="ja-JP" sz="1400" dirty="0">
+              <a:rPr lang="en-US" altLang="ja-JP" sz="900" dirty="0">
                 <a:latin typeface="Helvetica" pitchFamily="2" charset="0"/>
-                <a:ea typeface="BIZ UDGothic" panose="020B0400000000000000" pitchFamily="49" charset="-128"/>
               </a:rPr>
-              <a:t>PRS</a:t>
-            </a:r>
-            <a:r>
-              <a:rPr lang="ja-JP" altLang="en-US" sz="1400">
+              <a:t>SNP_C = 0.4</a:t>
+            </a:r>
+          </a:p>
+          <a:p>
+            <a:r>
+              <a:rPr lang="en-US" altLang="ja-JP" sz="900" dirty="0">
                 <a:latin typeface="Helvetica" pitchFamily="2" charset="0"/>
-                <a:ea typeface="BIZ UDGothic" panose="020B0400000000000000" pitchFamily="49" charset="-128"/>
               </a:rPr>
-              <a:t>に影響なし</a:t>
-            </a:r>
-            <a:endParaRPr lang="en-US" altLang="ja-JP" sz="1400" dirty="0">
-              <a:latin typeface="Helvetica" pitchFamily="2" charset="0"/>
-              <a:ea typeface="BIZ UDGothic" panose="020B0400000000000000" pitchFamily="49" charset="-128"/>
-            </a:endParaRPr>
+              <a:t>SNP_D = 0.2</a:t>
+            </a:r>
           </a:p>
         </p:txBody>
       </p:sp>
@@ -35732,7 +35702,7 @@
         <p:spPr>
           <a:xfrm>
             <a:off x="850220" y="2641680"/>
-            <a:ext cx="989373" cy="323165"/>
+            <a:ext cx="1531188" cy="323165"/>
           </a:xfrm>
           <a:prstGeom prst="rect">
             <a:avLst/>
@@ -35746,18 +35716,13 @@
           <a:lstStyle/>
           <a:p>
             <a:r>
-              <a:rPr lang="en-US" altLang="ja-JP" sz="1500" dirty="0">
+              <a:rPr lang="ja-JP" altLang="en-US" sz="1500">
                 <a:latin typeface="Arial" panose="020B0604020202020204" pitchFamily="34" charset="0"/>
                 <a:ea typeface="BIZ UDGothic" panose="020B0400000000000000" pitchFamily="49" charset="-128"/>
                 <a:cs typeface="Arial" panose="020B0604020202020204" pitchFamily="34" charset="0"/>
               </a:rPr>
-              <a:t>Deviation</a:t>
-            </a:r>
-            <a:endParaRPr lang="ja-JP" altLang="en-US" sz="1500">
-              <a:latin typeface="Arial" panose="020B0604020202020204" pitchFamily="34" charset="0"/>
-              <a:ea typeface="BIZ UDGothic" panose="020B0400000000000000" pitchFamily="49" charset="-128"/>
-              <a:cs typeface="Arial" panose="020B0604020202020204" pitchFamily="34" charset="0"/>
-            </a:endParaRPr>
+              <a:t>平均からの偏差</a:t>
+            </a:r>
           </a:p>
         </p:txBody>
       </p:sp>
@@ -37905,60 +37870,6 @@
       </p:sp>
       <p:sp>
         <p:nvSpPr>
-          <p:cNvPr id="6" name="右矢印 5">
-            <a:extLst>
-              <a:ext uri="{FF2B5EF4-FFF2-40B4-BE49-F238E27FC236}">
-                <a16:creationId xmlns:a16="http://schemas.microsoft.com/office/drawing/2014/main" id="{DEB59E2D-AF91-9D11-53BD-9BA94C699C06}"/>
-              </a:ext>
-            </a:extLst>
-          </p:cNvPr>
-          <p:cNvSpPr/>
-          <p:nvPr/>
-        </p:nvSpPr>
-        <p:spPr>
-          <a:xfrm>
-            <a:off x="8022067" y="1942535"/>
-            <a:ext cx="644265" cy="369332"/>
-          </a:xfrm>
-          <a:prstGeom prst="rightArrow">
-            <a:avLst/>
-          </a:prstGeom>
-          <a:solidFill>
-            <a:schemeClr val="bg1">
-              <a:lumMod val="75000"/>
-            </a:schemeClr>
-          </a:solidFill>
-          <a:ln>
-            <a:noFill/>
-          </a:ln>
-        </p:spPr>
-        <p:style>
-          <a:lnRef idx="2">
-            <a:schemeClr val="accent1">
-              <a:shade val="15000"/>
-            </a:schemeClr>
-          </a:lnRef>
-          <a:fillRef idx="1">
-            <a:schemeClr val="accent1"/>
-          </a:fillRef>
-          <a:effectRef idx="0">
-            <a:schemeClr val="accent1"/>
-          </a:effectRef>
-          <a:fontRef idx="minor">
-            <a:schemeClr val="lt1"/>
-          </a:fontRef>
-        </p:style>
-        <p:txBody>
-          <a:bodyPr rtlCol="0" anchor="ctr"/>
-          <a:lstStyle/>
-          <a:p>
-            <a:pPr algn="ctr"/>
-            <a:endParaRPr kumimoji="1" lang="ja-JP" altLang="en-US"/>
-          </a:p>
-        </p:txBody>
-      </p:sp>
-      <p:sp>
-        <p:nvSpPr>
           <p:cNvPr id="7" name="テキスト ボックス 6">
             <a:extLst>
               <a:ext uri="{FF2B5EF4-FFF2-40B4-BE49-F238E27FC236}">
@@ -37971,8 +37882,8 @@
         </p:nvSpPr>
         <p:spPr>
           <a:xfrm>
-            <a:off x="6739908" y="1891767"/>
-            <a:ext cx="1082348" cy="523220"/>
+            <a:off x="7026764" y="733369"/>
+            <a:ext cx="3377848" cy="2462213"/>
           </a:xfrm>
           <a:prstGeom prst="rect">
             <a:avLst/>
@@ -37986,6 +37897,22 @@
           <a:lstStyle/>
           <a:p>
             <a:r>
+              <a:rPr lang="ja-JP" altLang="en-US" sz="1400">
+                <a:latin typeface="Helvetica" pitchFamily="2" charset="0"/>
+                <a:ea typeface="BIZ UDGothic" panose="020B0400000000000000" pitchFamily="49" charset="-128"/>
+              </a:rPr>
+              <a:t>例</a:t>
+            </a:r>
+            <a:r>
+              <a:rPr lang="en-US" altLang="ja-JP" sz="1400" dirty="0">
+                <a:latin typeface="Helvetica" pitchFamily="2" charset="0"/>
+                <a:ea typeface="BIZ UDGothic" panose="020B0400000000000000" pitchFamily="49" charset="-128"/>
+              </a:rPr>
+              <a:t>) </a:t>
+            </a:r>
+          </a:p>
+          <a:p>
+            <a:r>
               <a:rPr lang="en-US" altLang="ja-JP" sz="1400" dirty="0">
                 <a:latin typeface="Helvetica" pitchFamily="2" charset="0"/>
                 <a:ea typeface="BIZ UDGothic" panose="020B0400000000000000" pitchFamily="49" charset="-128"/>
@@ -37997,7 +37924,21 @@
                 <a:latin typeface="Helvetica" pitchFamily="2" charset="0"/>
                 <a:ea typeface="BIZ UDGothic" panose="020B0400000000000000" pitchFamily="49" charset="-128"/>
               </a:rPr>
-              <a:t>の</a:t>
+              <a:t>のような</a:t>
+            </a:r>
+            <a:r>
+              <a:rPr lang="en-US" altLang="ja-JP" sz="1400" dirty="0">
+                <a:latin typeface="Helvetica" pitchFamily="2" charset="0"/>
+                <a:ea typeface="BIZ UDGothic" panose="020B0400000000000000" pitchFamily="49" charset="-128"/>
+              </a:rPr>
+              <a:t>Allele</a:t>
+            </a:r>
+            <a:r>
+              <a:rPr lang="ja-JP" altLang="en-US" sz="1400">
+                <a:latin typeface="Helvetica" pitchFamily="2" charset="0"/>
+                <a:ea typeface="BIZ UDGothic" panose="020B0400000000000000" pitchFamily="49" charset="-128"/>
+              </a:rPr>
+              <a:t>の存在を仮定する</a:t>
             </a:r>
             <a:endParaRPr lang="en-US" altLang="ja-JP" sz="1400" dirty="0">
               <a:latin typeface="Helvetica" pitchFamily="2" charset="0"/>
@@ -38010,8 +37951,102 @@
                 <a:latin typeface="Helvetica" pitchFamily="2" charset="0"/>
                 <a:ea typeface="BIZ UDGothic" panose="020B0400000000000000" pitchFamily="49" charset="-128"/>
               </a:rPr>
-              <a:t>存在を仮定</a:t>
-            </a:r>
+              <a:t>健常者と患者で頻度同じ</a:t>
+            </a:r>
+            <a:endParaRPr lang="en-US" altLang="ja-JP" sz="1400" dirty="0">
+              <a:latin typeface="Helvetica" pitchFamily="2" charset="0"/>
+              <a:ea typeface="BIZ UDGothic" panose="020B0400000000000000" pitchFamily="49" charset="-128"/>
+            </a:endParaRPr>
+          </a:p>
+          <a:p>
+            <a:r>
+              <a:rPr lang="ja-JP" altLang="en-US" sz="1400">
+                <a:latin typeface="Helvetica" pitchFamily="2" charset="0"/>
+                <a:ea typeface="BIZ UDGothic" panose="020B0400000000000000" pitchFamily="49" charset="-128"/>
+              </a:rPr>
+              <a:t>すなわち、</a:t>
+            </a:r>
+            <a:r>
+              <a:rPr lang="en-US" altLang="ja-JP" sz="1400" dirty="0">
+                <a:latin typeface="Helvetica" pitchFamily="2" charset="0"/>
+                <a:ea typeface="BIZ UDGothic" panose="020B0400000000000000" pitchFamily="49" charset="-128"/>
+              </a:rPr>
+              <a:t>β=0</a:t>
+            </a:r>
+            <a:r>
+              <a:rPr lang="ja-JP" altLang="en-US" sz="1400">
+                <a:latin typeface="Helvetica" pitchFamily="2" charset="0"/>
+                <a:ea typeface="BIZ UDGothic" panose="020B0400000000000000" pitchFamily="49" charset="-128"/>
+              </a:rPr>
+              <a:t>、</a:t>
+            </a:r>
+            <a:r>
+              <a:rPr lang="en-US" altLang="ja-JP" sz="1400" dirty="0">
+                <a:latin typeface="Helvetica" pitchFamily="2" charset="0"/>
+                <a:ea typeface="BIZ UDGothic" panose="020B0400000000000000" pitchFamily="49" charset="-128"/>
+              </a:rPr>
+              <a:t>PRS</a:t>
+            </a:r>
+            <a:r>
+              <a:rPr lang="ja-JP" altLang="en-US" sz="1400">
+                <a:latin typeface="Helvetica" pitchFamily="2" charset="0"/>
+                <a:ea typeface="BIZ UDGothic" panose="020B0400000000000000" pitchFamily="49" charset="-128"/>
+              </a:rPr>
+              <a:t>に影響しない</a:t>
+            </a:r>
+            <a:endParaRPr lang="en-US" altLang="ja-JP" sz="1400" dirty="0">
+              <a:latin typeface="Helvetica" pitchFamily="2" charset="0"/>
+              <a:ea typeface="BIZ UDGothic" panose="020B0400000000000000" pitchFamily="49" charset="-128"/>
+            </a:endParaRPr>
+          </a:p>
+          <a:p>
+            <a:endParaRPr lang="en-US" altLang="ja-JP" sz="1400" dirty="0">
+              <a:latin typeface="Helvetica" pitchFamily="2" charset="0"/>
+              <a:ea typeface="BIZ UDGothic" panose="020B0400000000000000" pitchFamily="49" charset="-128"/>
+            </a:endParaRPr>
+          </a:p>
+          <a:p>
+            <a:r>
+              <a:rPr lang="ja-JP" altLang="en-US" sz="1400">
+                <a:latin typeface="Helvetica" pitchFamily="2" charset="0"/>
+                <a:ea typeface="BIZ UDGothic" panose="020B0400000000000000" pitchFamily="49" charset="-128"/>
+              </a:rPr>
+              <a:t>なし</a:t>
+            </a:r>
+            <a:endParaRPr lang="en-US" altLang="ja-JP" sz="1400" dirty="0">
+              <a:latin typeface="Helvetica" pitchFamily="2" charset="0"/>
+              <a:ea typeface="BIZ UDGothic" panose="020B0400000000000000" pitchFamily="49" charset="-128"/>
+            </a:endParaRPr>
+          </a:p>
+          <a:p>
+            <a:endParaRPr lang="en-US" altLang="ja-JP" sz="1400" dirty="0">
+              <a:latin typeface="Helvetica" pitchFamily="2" charset="0"/>
+              <a:ea typeface="BIZ UDGothic" panose="020B0400000000000000" pitchFamily="49" charset="-128"/>
+            </a:endParaRPr>
+          </a:p>
+          <a:p>
+            <a:endParaRPr lang="en-US" altLang="ja-JP" sz="1400" dirty="0">
+              <a:latin typeface="Helvetica" pitchFamily="2" charset="0"/>
+              <a:ea typeface="BIZ UDGothic" panose="020B0400000000000000" pitchFamily="49" charset="-128"/>
+            </a:endParaRPr>
+          </a:p>
+          <a:p>
+            <a:endParaRPr lang="en-US" altLang="ja-JP" sz="1400" dirty="0">
+              <a:latin typeface="Helvetica" pitchFamily="2" charset="0"/>
+              <a:ea typeface="BIZ UDGothic" panose="020B0400000000000000" pitchFamily="49" charset="-128"/>
+            </a:endParaRPr>
+          </a:p>
+          <a:p>
+            <a:endParaRPr lang="en-US" altLang="ja-JP" sz="1400" dirty="0">
+              <a:latin typeface="Helvetica" pitchFamily="2" charset="0"/>
+              <a:ea typeface="BIZ UDGothic" panose="020B0400000000000000" pitchFamily="49" charset="-128"/>
+            </a:endParaRPr>
+          </a:p>
+          <a:p>
+            <a:endParaRPr lang="ja-JP" altLang="en-US" sz="1400">
+              <a:latin typeface="Helvetica" pitchFamily="2" charset="0"/>
+              <a:ea typeface="BIZ UDGothic" panose="020B0400000000000000" pitchFamily="49" charset="-128"/>
+            </a:endParaRPr>
           </a:p>
         </p:txBody>
       </p:sp>
@@ -38654,7 +38689,7 @@
         <p:spPr>
           <a:xfrm>
             <a:off x="850220" y="4415150"/>
-            <a:ext cx="989373" cy="553998"/>
+            <a:ext cx="1146468" cy="553998"/>
           </a:xfrm>
           <a:prstGeom prst="rect">
             <a:avLst/>
@@ -38668,87 +38703,27 @@
           <a:lstStyle/>
           <a:p>
             <a:r>
-              <a:rPr lang="en-US" altLang="ja-JP" sz="1500" dirty="0">
-                <a:latin typeface="Arial" panose="020B0604020202020204" pitchFamily="34" charset="0"/>
-                <a:ea typeface="BIZ UDGothic" panose="020B0400000000000000" pitchFamily="49" charset="-128"/>
-                <a:cs typeface="Arial" panose="020B0604020202020204" pitchFamily="34" charset="0"/>
-              </a:rPr>
-              <a:t>Deviation</a:t>
-            </a:r>
-          </a:p>
-          <a:p>
-            <a:r>
               <a:rPr lang="ja-JP" altLang="en-US" sz="1500">
                 <a:latin typeface="Arial" panose="020B0604020202020204" pitchFamily="34" charset="0"/>
                 <a:ea typeface="BIZ UDGothic" panose="020B0400000000000000" pitchFamily="49" charset="-128"/>
                 <a:cs typeface="Arial" panose="020B0604020202020204" pitchFamily="34" charset="0"/>
               </a:rPr>
-              <a:t>リスト</a:t>
-            </a:r>
-          </a:p>
-        </p:txBody>
-      </p:sp>
-      <p:sp>
-        <p:nvSpPr>
-          <p:cNvPr id="97" name="テキスト ボックス 96">
-            <a:extLst>
-              <a:ext uri="{FF2B5EF4-FFF2-40B4-BE49-F238E27FC236}">
-                <a16:creationId xmlns:a16="http://schemas.microsoft.com/office/drawing/2014/main" id="{8B038E0F-4CA1-A0E4-EDAD-126CB838124E}"/>
-              </a:ext>
-            </a:extLst>
-          </p:cNvPr>
-          <p:cNvSpPr txBox="1"/>
-          <p:nvPr/>
-        </p:nvSpPr>
-        <p:spPr>
-          <a:xfrm>
-            <a:off x="3359312" y="4674108"/>
-            <a:ext cx="1292341" cy="523220"/>
-          </a:xfrm>
-          <a:prstGeom prst="rect">
-            <a:avLst/>
-          </a:prstGeom>
-          <a:noFill/>
-        </p:spPr>
-        <p:txBody>
-          <a:bodyPr wrap="none" rtlCol="0">
-            <a:spAutoFit/>
-          </a:bodyPr>
-          <a:lstStyle/>
-          <a:p>
-            <a:r>
-              <a:rPr lang="en-US" altLang="ja-JP" sz="1400" dirty="0">
-                <a:latin typeface="Helvetica" pitchFamily="2" charset="0"/>
-                <a:ea typeface="BIZ UDGothic" panose="020B0400000000000000" pitchFamily="49" charset="-128"/>
-              </a:rPr>
-              <a:t>Cntl01</a:t>
-            </a:r>
-            <a:r>
-              <a:rPr lang="ja-JP" altLang="en-US" sz="1400">
-                <a:latin typeface="Helvetica" pitchFamily="2" charset="0"/>
-                <a:ea typeface="BIZ UDGothic" panose="020B0400000000000000" pitchFamily="49" charset="-128"/>
-              </a:rPr>
-              <a:t>と</a:t>
-            </a:r>
-            <a:endParaRPr lang="en-US" altLang="ja-JP" sz="1400" dirty="0">
-              <a:latin typeface="Helvetica" pitchFamily="2" charset="0"/>
+              <a:t>個人毎</a:t>
+            </a:r>
+            <a:endParaRPr lang="en-US" altLang="ja-JP" sz="1500" dirty="0">
+              <a:latin typeface="Arial" panose="020B0604020202020204" pitchFamily="34" charset="0"/>
               <a:ea typeface="BIZ UDGothic" panose="020B0400000000000000" pitchFamily="49" charset="-128"/>
+              <a:cs typeface="Arial" panose="020B0604020202020204" pitchFamily="34" charset="0"/>
             </a:endParaRPr>
           </a:p>
           <a:p>
             <a:r>
-              <a:rPr lang="en-US" altLang="ja-JP" sz="1400" dirty="0">
-                <a:latin typeface="Helvetica" pitchFamily="2" charset="0"/>
+              <a:rPr lang="ja-JP" altLang="en-US" sz="1500">
+                <a:latin typeface="Arial" panose="020B0604020202020204" pitchFamily="34" charset="0"/>
                 <a:ea typeface="BIZ UDGothic" panose="020B0400000000000000" pitchFamily="49" charset="-128"/>
+                <a:cs typeface="Arial" panose="020B0604020202020204" pitchFamily="34" charset="0"/>
               </a:rPr>
-              <a:t>ASD03</a:t>
-            </a:r>
-            <a:r>
-              <a:rPr lang="ja-JP" altLang="en-US" sz="1400">
-                <a:latin typeface="Helvetica" pitchFamily="2" charset="0"/>
-                <a:ea typeface="BIZ UDGothic" panose="020B0400000000000000" pitchFamily="49" charset="-128"/>
-              </a:rPr>
-              <a:t>に注目</a:t>
+              <a:t>偏差リスト</a:t>
             </a:r>
           </a:p>
         </p:txBody>
@@ -39128,153 +39103,6 @@
       </p:cxnSp>
       <p:sp>
         <p:nvSpPr>
-          <p:cNvPr id="111" name="テキスト ボックス 110">
-            <a:extLst>
-              <a:ext uri="{FF2B5EF4-FFF2-40B4-BE49-F238E27FC236}">
-                <a16:creationId xmlns:a16="http://schemas.microsoft.com/office/drawing/2014/main" id="{0203648F-1B32-9980-FFA1-701E2DB70620}"/>
-              </a:ext>
-            </a:extLst>
-          </p:cNvPr>
-          <p:cNvSpPr txBox="1"/>
-          <p:nvPr/>
-        </p:nvSpPr>
-        <p:spPr>
-          <a:xfrm>
-            <a:off x="6944040" y="1461414"/>
-            <a:ext cx="518091" cy="369332"/>
-          </a:xfrm>
-          <a:prstGeom prst="rect">
-            <a:avLst/>
-          </a:prstGeom>
-          <a:solidFill>
-            <a:schemeClr val="bg1"/>
-          </a:solidFill>
-          <a:ln w="19050">
-            <a:solidFill>
-              <a:schemeClr val="tx1"/>
-            </a:solidFill>
-          </a:ln>
-        </p:spPr>
-        <p:txBody>
-          <a:bodyPr wrap="none" rtlCol="0">
-            <a:spAutoFit/>
-          </a:bodyPr>
-          <a:lstStyle/>
-          <a:p>
-            <a:r>
-              <a:rPr kumimoji="1" lang="en-US" altLang="ja-JP" dirty="0">
-                <a:latin typeface="Helvetica" pitchFamily="2" charset="0"/>
-                <a:ea typeface="BIZ UDGothic" panose="020B0400000000000000" pitchFamily="49" charset="-128"/>
-              </a:rPr>
-              <a:t>4-1</a:t>
-            </a:r>
-            <a:endParaRPr kumimoji="1" lang="ja-JP" altLang="en-US">
-              <a:latin typeface="Helvetica" pitchFamily="2" charset="0"/>
-              <a:ea typeface="BIZ UDGothic" panose="020B0400000000000000" pitchFamily="49" charset="-128"/>
-            </a:endParaRPr>
-          </a:p>
-        </p:txBody>
-      </p:sp>
-      <p:sp>
-        <p:nvSpPr>
-          <p:cNvPr id="112" name="テキスト ボックス 111">
-            <a:extLst>
-              <a:ext uri="{FF2B5EF4-FFF2-40B4-BE49-F238E27FC236}">
-                <a16:creationId xmlns:a16="http://schemas.microsoft.com/office/drawing/2014/main" id="{0CEEB33D-51B2-C03B-391E-A8EDDB7346B1}"/>
-              </a:ext>
-            </a:extLst>
-          </p:cNvPr>
-          <p:cNvSpPr txBox="1"/>
-          <p:nvPr/>
-        </p:nvSpPr>
-        <p:spPr>
-          <a:xfrm>
-            <a:off x="9003758" y="1461414"/>
-            <a:ext cx="518091" cy="369332"/>
-          </a:xfrm>
-          <a:prstGeom prst="rect">
-            <a:avLst/>
-          </a:prstGeom>
-          <a:solidFill>
-            <a:schemeClr val="bg1"/>
-          </a:solidFill>
-          <a:ln w="19050">
-            <a:solidFill>
-              <a:schemeClr val="tx1"/>
-            </a:solidFill>
-          </a:ln>
-        </p:spPr>
-        <p:txBody>
-          <a:bodyPr wrap="none" rtlCol="0">
-            <a:spAutoFit/>
-          </a:bodyPr>
-          <a:lstStyle/>
-          <a:p>
-            <a:r>
-              <a:rPr kumimoji="1" lang="en-US" altLang="ja-JP" dirty="0">
-                <a:latin typeface="Helvetica" pitchFamily="2" charset="0"/>
-                <a:ea typeface="BIZ UDGothic" panose="020B0400000000000000" pitchFamily="49" charset="-128"/>
-              </a:rPr>
-              <a:t>4-2</a:t>
-            </a:r>
-            <a:endParaRPr kumimoji="1" lang="ja-JP" altLang="en-US">
-              <a:latin typeface="Helvetica" pitchFamily="2" charset="0"/>
-              <a:ea typeface="BIZ UDGothic" panose="020B0400000000000000" pitchFamily="49" charset="-128"/>
-            </a:endParaRPr>
-          </a:p>
-        </p:txBody>
-      </p:sp>
-      <p:sp>
-        <p:nvSpPr>
-          <p:cNvPr id="113" name="テキスト ボックス 112">
-            <a:extLst>
-              <a:ext uri="{FF2B5EF4-FFF2-40B4-BE49-F238E27FC236}">
-                <a16:creationId xmlns:a16="http://schemas.microsoft.com/office/drawing/2014/main" id="{648DB75E-7180-1905-1EAB-2BFC82EAEA9B}"/>
-              </a:ext>
-            </a:extLst>
-          </p:cNvPr>
-          <p:cNvSpPr txBox="1"/>
-          <p:nvPr/>
-        </p:nvSpPr>
-        <p:spPr>
-          <a:xfrm>
-            <a:off x="4306551" y="4491721"/>
-            <a:ext cx="518091" cy="369332"/>
-          </a:xfrm>
-          <a:prstGeom prst="rect">
-            <a:avLst/>
-          </a:prstGeom>
-          <a:solidFill>
-            <a:schemeClr val="bg1"/>
-          </a:solidFill>
-          <a:ln w="19050">
-            <a:solidFill>
-              <a:schemeClr val="tx1"/>
-            </a:solidFill>
-          </a:ln>
-        </p:spPr>
-        <p:txBody>
-          <a:bodyPr wrap="none" rtlCol="0">
-            <a:spAutoFit/>
-          </a:bodyPr>
-          <a:lstStyle/>
-          <a:p>
-            <a:r>
-              <a:rPr kumimoji="1" lang="en-US" altLang="ja-JP" dirty="0">
-                <a:latin typeface="Helvetica" pitchFamily="2" charset="0"/>
-                <a:ea typeface="BIZ UDGothic" panose="020B0400000000000000" pitchFamily="49" charset="-128"/>
-              </a:rPr>
-              <a:t>4-3</a:t>
-            </a:r>
-            <a:endParaRPr kumimoji="1" lang="ja-JP" altLang="en-US">
-              <a:latin typeface="Helvetica" pitchFamily="2" charset="0"/>
-              <a:ea typeface="BIZ UDGothic" panose="020B0400000000000000" pitchFamily="49" charset="-128"/>
-            </a:endParaRPr>
-          </a:p>
-        </p:txBody>
-      </p:sp>
-      <p:sp>
-        <p:nvSpPr>
           <p:cNvPr id="118" name="正方形/長方形 117">
             <a:extLst>
               <a:ext uri="{FF2B5EF4-FFF2-40B4-BE49-F238E27FC236}">
@@ -39775,10 +39603,10 @@
       </p:sp>
       <p:sp>
         <p:nvSpPr>
-          <p:cNvPr id="130" name="テキスト ボックス 129">
+          <p:cNvPr id="2" name="テキスト ボックス 1">
             <a:extLst>
               <a:ext uri="{FF2B5EF4-FFF2-40B4-BE49-F238E27FC236}">
-                <a16:creationId xmlns:a16="http://schemas.microsoft.com/office/drawing/2014/main" id="{7EB266FF-3FD9-950A-542C-606CFB9166CC}"/>
+                <a16:creationId xmlns:a16="http://schemas.microsoft.com/office/drawing/2014/main" id="{F663A329-BCEB-B8C6-30B2-68841DD43A42}"/>
               </a:ext>
             </a:extLst>
           </p:cNvPr>
@@ -39787,20 +39615,13 @@
         </p:nvSpPr>
         <p:spPr>
           <a:xfrm>
-            <a:off x="8008443" y="3207095"/>
-            <a:ext cx="518091" cy="369332"/>
+            <a:off x="5599242" y="2127567"/>
+            <a:ext cx="2262158" cy="646331"/>
           </a:xfrm>
           <a:prstGeom prst="rect">
             <a:avLst/>
           </a:prstGeom>
-          <a:solidFill>
-            <a:schemeClr val="bg1"/>
-          </a:solidFill>
-          <a:ln w="19050">
-            <a:solidFill>
-              <a:schemeClr val="tx1"/>
-            </a:solidFill>
-          </a:ln>
+          <a:noFill/>
         </p:spPr>
         <p:txBody>
           <a:bodyPr wrap="none" rtlCol="0">
@@ -39809,16 +39630,120 @@
           <a:lstStyle/>
           <a:p>
             <a:r>
-              <a:rPr kumimoji="1" lang="en-US" altLang="ja-JP" dirty="0">
-                <a:latin typeface="Helvetica" pitchFamily="2" charset="0"/>
-                <a:ea typeface="BIZ UDGothic" panose="020B0400000000000000" pitchFamily="49" charset="-128"/>
+              <a:rPr kumimoji="1" lang="ja-JP" altLang="en-US"/>
+              <a:t>個人毎に偏差を出す</a:t>
+            </a:r>
+            <a:endParaRPr kumimoji="1" lang="en-US" altLang="ja-JP" dirty="0"/>
+          </a:p>
+          <a:p>
+            <a:r>
+              <a:rPr lang="en-US" altLang="ja-JP" dirty="0"/>
+              <a:t>Beta</a:t>
+            </a:r>
+            <a:r>
+              <a:rPr lang="ja-JP" altLang="en-US"/>
+              <a:t>とは関係ない</a:t>
+            </a:r>
+            <a:endParaRPr kumimoji="1" lang="ja-JP" altLang="en-US"/>
+          </a:p>
+        </p:txBody>
+      </p:sp>
+      <p:sp>
+        <p:nvSpPr>
+          <p:cNvPr id="16" name="テキスト ボックス 15">
+            <a:extLst>
+              <a:ext uri="{FF2B5EF4-FFF2-40B4-BE49-F238E27FC236}">
+                <a16:creationId xmlns:a16="http://schemas.microsoft.com/office/drawing/2014/main" id="{AF63717D-4187-BB36-5429-8C6C800A5926}"/>
+              </a:ext>
+            </a:extLst>
+          </p:cNvPr>
+          <p:cNvSpPr txBox="1"/>
+          <p:nvPr/>
+        </p:nvSpPr>
+        <p:spPr>
+          <a:xfrm>
+            <a:off x="2965391" y="2649196"/>
+            <a:ext cx="8787983" cy="369332"/>
+          </a:xfrm>
+          <a:prstGeom prst="rect">
+            <a:avLst/>
+          </a:prstGeom>
+          <a:noFill/>
+        </p:spPr>
+        <p:txBody>
+          <a:bodyPr wrap="none" rtlCol="0">
+            <a:spAutoFit/>
+          </a:bodyPr>
+          <a:lstStyle/>
+          <a:p>
+            <a:r>
+              <a:rPr kumimoji="1" lang="ja-JP" altLang="en-US"/>
+              <a:t>その</a:t>
+            </a:r>
+            <a:r>
+              <a:rPr kumimoji="1" lang="en-US" altLang="ja-JP" dirty="0"/>
+              <a:t>allele</a:t>
+            </a:r>
+            <a:r>
+              <a:rPr kumimoji="1" lang="ja-JP" altLang="en-US"/>
+              <a:t>が</a:t>
+            </a:r>
+            <a:r>
+              <a:rPr kumimoji="1" lang="ja-JP" altLang="en-US">
+                <a:solidFill>
+                  <a:srgbClr val="FF0000"/>
+                </a:solidFill>
               </a:rPr>
-              <a:t>4-4</a:t>
-            </a:r>
-            <a:endParaRPr kumimoji="1" lang="ja-JP" altLang="en-US">
-              <a:latin typeface="Helvetica" pitchFamily="2" charset="0"/>
-              <a:ea typeface="BIZ UDGothic" panose="020B0400000000000000" pitchFamily="49" charset="-128"/>
-            </a:endParaRPr>
+              <a:t>健常者</a:t>
+            </a:r>
+            <a:r>
+              <a:rPr kumimoji="1" lang="ja-JP" altLang="en-US"/>
+              <a:t>平均からどのくらい逸脱しているか</a:t>
+            </a:r>
+            <a:r>
+              <a:rPr kumimoji="1" lang="en-US" altLang="ja-JP" dirty="0"/>
+              <a:t>=</a:t>
+            </a:r>
+            <a:r>
+              <a:rPr kumimoji="1" lang="ja-JP" altLang="en-US"/>
+              <a:t>その個人において特徴的か</a:t>
+            </a:r>
+          </a:p>
+        </p:txBody>
+      </p:sp>
+      <p:sp>
+        <p:nvSpPr>
+          <p:cNvPr id="21" name="テキスト ボックス 20">
+            <a:extLst>
+              <a:ext uri="{FF2B5EF4-FFF2-40B4-BE49-F238E27FC236}">
+                <a16:creationId xmlns:a16="http://schemas.microsoft.com/office/drawing/2014/main" id="{F54A328A-EB1F-9643-98BE-59EE48A8A328}"/>
+              </a:ext>
+            </a:extLst>
+          </p:cNvPr>
+          <p:cNvSpPr txBox="1"/>
+          <p:nvPr/>
+        </p:nvSpPr>
+        <p:spPr>
+          <a:xfrm>
+            <a:off x="623843" y="3050849"/>
+            <a:ext cx="383438" cy="369332"/>
+          </a:xfrm>
+          <a:prstGeom prst="rect">
+            <a:avLst/>
+          </a:prstGeom>
+          <a:noFill/>
+        </p:spPr>
+        <p:txBody>
+          <a:bodyPr wrap="none" rtlCol="0">
+            <a:spAutoFit/>
+          </a:bodyPr>
+          <a:lstStyle/>
+          <a:p>
+            <a:r>
+              <a:rPr kumimoji="1" lang="en-US" altLang="ja-JP" dirty="0"/>
+              <a:t>fc</a:t>
+            </a:r>
+            <a:endParaRPr kumimoji="1" lang="ja-JP" altLang="en-US"/>
           </a:p>
         </p:txBody>
       </p:sp>

</xml_diff>